<commit_message>
v2.45 omslag en inhoudsopgave gescheiden, PowerPoint alsnog op site
</commit_message>
<xml_diff>
--- a/public/ai-koers/NHL-Stenden-AI-Koers-presentatie.pptx
+++ b/public/ai-koers/NHL-Stenden-AI-Koers-presentatie.pptx
@@ -2140,6 +2140,10 @@
           </a:solidFill>
           <a:ln/>
         </p:spPr>
+        <p:txBody>
+          <a:bodyPr/>
+          <a:p/>
+        </p:txBody>
       </p:sp>
       <p:sp>
         <p:nvSpPr>
@@ -2162,6 +2166,10 @@
           </a:solidFill>
           <a:ln/>
         </p:spPr>
+        <p:txBody>
+          <a:bodyPr/>
+          <a:p/>
+        </p:txBody>
       </p:sp>
       <p:sp>
         <p:nvSpPr>
@@ -2182,6 +2190,10 @@
           </a:solidFill>
           <a:ln/>
         </p:spPr>
+        <p:txBody>
+          <a:bodyPr/>
+          <a:p/>
+        </p:txBody>
       </p:sp>
       <p:sp>
         <p:nvSpPr>
@@ -2204,89 +2216,9 @@
           </a:solidFill>
           <a:ln/>
         </p:spPr>
-      </p:sp>
-      <p:sp>
-        <p:nvSpPr>
-          <p:cNvPr id="6" name="Shape 4"/>
-          <p:cNvSpPr/>
-          <p:nvPr/>
-        </p:nvSpPr>
-        <p:spPr>
-          <a:xfrm>
-            <a:off x="685800" y="640080"/>
-            <a:ext cx="1417320" cy="914400"/>
-          </a:xfrm>
-          <a:prstGeom prst="rect">
-            <a:avLst/>
-          </a:prstGeom>
-          <a:ln w="38100">
-            <a:solidFill>
-              <a:srgbClr val="FFFFFF"/>
-            </a:solidFill>
-            <a:prstDash val="solid"/>
-          </a:ln>
-        </p:spPr>
-      </p:sp>
-      <p:sp>
-        <p:nvSpPr>
-          <p:cNvPr id="7" name="Text 5"/>
-          <p:cNvSpPr/>
-          <p:nvPr/>
-        </p:nvSpPr>
-        <p:spPr>
-          <a:xfrm>
-            <a:off x="777240" y="676656"/>
-            <a:ext cx="1280160" cy="841248"/>
-          </a:xfrm>
-          <a:prstGeom prst="rect">
-            <a:avLst/>
-          </a:prstGeom>
-          <a:noFill/>
-          <a:ln/>
-        </p:spPr>
-        <p:txBody>
-          <a:bodyPr wrap="square" lIns="0" tIns="0" rIns="0" bIns="0" rtlCol="0" anchor="ctr"/>
-          <a:lstStyle/>
-          <a:p>
-            <a:pPr indent="0" marL="0">
-              <a:lnSpc>
-                <a:spcPts val="1700"/>
-              </a:lnSpc>
-              <a:buNone/>
-            </a:pPr>
-            <a:r>
-              <a:rPr lang="en-US" sz="1500" b="1" dirty="0">
-                <a:solidFill>
-                  <a:srgbClr val="FFFFFF"/>
-                </a:solidFill>
-                <a:latin typeface="Arial" pitchFamily="34" charset="0"/>
-                <a:ea typeface="Arial" pitchFamily="34" charset="-122"/>
-                <a:cs typeface="Arial" pitchFamily="34" charset="-120"/>
-              </a:rPr>
-              <a:t>NHL</a:t>
-            </a:r>
-            <a:endParaRPr lang="en-US" sz="1500" dirty="0"/>
-          </a:p>
-          <a:p>
-            <a:pPr indent="0" marL="0">
-              <a:lnSpc>
-                <a:spcPts val="1700"/>
-              </a:lnSpc>
-              <a:buNone/>
-            </a:pPr>
-            <a:r>
-              <a:rPr lang="en-US" sz="1500" b="1" dirty="0">
-                <a:solidFill>
-                  <a:srgbClr val="FFFFFF"/>
-                </a:solidFill>
-                <a:latin typeface="Arial" pitchFamily="34" charset="0"/>
-                <a:ea typeface="Arial" pitchFamily="34" charset="-122"/>
-                <a:cs typeface="Arial" pitchFamily="34" charset="-120"/>
-              </a:rPr>
-              <a:t>STENDEN</a:t>
-            </a:r>
-            <a:endParaRPr lang="en-US" sz="1500" dirty="0"/>
-          </a:p>
+        <p:txBody>
+          <a:bodyPr/>
+          <a:p/>
         </p:txBody>
       </p:sp>
       <p:sp>
@@ -2484,6 +2416,30 @@
           </a:p>
         </p:txBody>
       </p:sp>
+      <p:pic>
+        <p:nvPicPr>
+          <p:cNvPr id="13" name="Picture 12" descr="nhl-logo-transparent.png"/>
+          <p:cNvPicPr>
+            <a:picLocks noChangeAspect="1"/>
+          </p:cNvPicPr>
+          <p:nvPr/>
+        </p:nvPicPr>
+        <p:blipFill>
+          <a:blip r:embed="rId3"/>
+          <a:stretch>
+            <a:fillRect/>
+          </a:stretch>
+        </p:blipFill>
+        <p:spPr>
+          <a:xfrm>
+            <a:off x="994460" y="697280"/>
+            <a:ext cx="800000" cy="800000"/>
+          </a:xfrm>
+          <a:prstGeom prst="rect">
+            <a:avLst/>
+          </a:prstGeom>
+        </p:spPr>
+      </p:pic>
     </p:spTree>
   </p:cSld>
   <p:clrMapOvr>

</xml_diff>